<commit_message>
Cierre del curso: publica los exámenes aplicados (parcial y final, variantes A/B con clave), los quizzes de cada tramo y el material de apoyo (proyecto de curso, portafolio + pitch, ejemplos); actualiza slides 3-9 y Tarea 5 (ediciones del docente)
</commit_message>
<xml_diff>
--- a/slides/sesion-08.pptx
+++ b/slides/sesion-08.pptx
@@ -5,17 +5,17 @@
     <p:sldMasterId id="2147483648" r:id="rId1"/>
   </p:sldMasterIdLst>
   <p:sldIdLst>
-    <p:sldId id="256" r:id="rId7"/>
-    <p:sldId id="257" r:id="rId8"/>
-    <p:sldId id="258" r:id="rId9"/>
-    <p:sldId id="259" r:id="rId10"/>
-    <p:sldId id="260" r:id="rId11"/>
-    <p:sldId id="261" r:id="rId12"/>
-    <p:sldId id="262" r:id="rId13"/>
-    <p:sldId id="263" r:id="rId14"/>
-    <p:sldId id="264" r:id="rId15"/>
+    <p:sldId id="256" r:id="rId2"/>
+    <p:sldId id="257" r:id="rId3"/>
+    <p:sldId id="258" r:id="rId4"/>
+    <p:sldId id="259" r:id="rId5"/>
+    <p:sldId id="260" r:id="rId6"/>
+    <p:sldId id="261" r:id="rId7"/>
+    <p:sldId id="262" r:id="rId8"/>
+    <p:sldId id="263" r:id="rId9"/>
+    <p:sldId id="264" r:id="rId10"/>
   </p:sldIdLst>
-  <p:sldSz cx="12191695" cy="6858000" type="screen4x3"/>
+  <p:sldSz cx="12192000" cy="6858000"/>
   <p:notesSz cx="6858000" cy="9144000"/>
   <p:defaultTextStyle>
     <a:defPPr>
@@ -112,6 +112,22 @@
       </a:defRPr>
     </a:lvl9pPr>
   </p:defaultTextStyle>
+  <p:extLst>
+    <p:ext uri="{EFAFB233-063F-42B5-8137-9DF3F51BA10A}">
+      <p15:sldGuideLst xmlns:p15="http://schemas.microsoft.com/office/powerpoint/2012/main">
+        <p15:guide id="1" orient="horz" pos="2160">
+          <p15:clr>
+            <a:srgbClr val="A4A3A4"/>
+          </p15:clr>
+        </p15:guide>
+        <p15:guide id="2" pos="2880">
+          <p15:clr>
+            <a:srgbClr val="A4A3A4"/>
+          </p15:clr>
+        </p15:guide>
+      </p15:sldGuideLst>
+    </p:ext>
+  </p:extLst>
 </p:presentation>
 </file>
 
@@ -153,10 +169,9 @@
           <a:lstStyle/>
           <a:p>
             <a:r>
-              <a:rPr lang="en-US" smtClean="0"/>
+              <a:rPr lang="en-US"/>
               <a:t>Click to edit Master title style</a:t>
             </a:r>
-            <a:endParaRPr lang="en-US"/>
           </a:p>
         </p:txBody>
       </p:sp>
@@ -272,10 +287,9 @@
           </a:lstStyle>
           <a:p>
             <a:r>
-              <a:rPr lang="en-US" smtClean="0"/>
+              <a:rPr lang="en-US"/>
               <a:t>Click to edit Master subtitle style</a:t>
             </a:r>
-            <a:endParaRPr lang="en-US"/>
           </a:p>
         </p:txBody>
       </p:sp>
@@ -296,7 +310,7 @@
           <a:p>
             <a:fld id="{5BCAD085-E8A6-8845-BD4E-CB4CCA059FC4}" type="datetimeFigureOut">
               <a:rPr lang="en-US" smtClean="0"/>
-              <a:t>1/27/13</a:t>
+              <a:t>8/17/26</a:t>
             </a:fld>
             <a:endParaRPr lang="en-US"/>
           </a:p>
@@ -390,10 +404,9 @@
           <a:lstStyle/>
           <a:p>
             <a:r>
-              <a:rPr lang="en-US" smtClean="0"/>
+              <a:rPr lang="en-US"/>
               <a:t>Click to edit Master title style</a:t>
             </a:r>
-            <a:endParaRPr lang="en-US"/>
           </a:p>
         </p:txBody>
       </p:sp>
@@ -414,38 +427,37 @@
           <a:p>
             <a:pPr lvl="0"/>
             <a:r>
-              <a:rPr lang="en-US" smtClean="0"/>
+              <a:rPr lang="en-US"/>
               <a:t>Click to edit Master text styles</a:t>
             </a:r>
           </a:p>
           <a:p>
             <a:pPr lvl="1"/>
             <a:r>
-              <a:rPr lang="en-US" smtClean="0"/>
+              <a:rPr lang="en-US"/>
               <a:t>Second level</a:t>
             </a:r>
           </a:p>
           <a:p>
             <a:pPr lvl="2"/>
             <a:r>
-              <a:rPr lang="en-US" smtClean="0"/>
+              <a:rPr lang="en-US"/>
               <a:t>Third level</a:t>
             </a:r>
           </a:p>
           <a:p>
             <a:pPr lvl="3"/>
             <a:r>
-              <a:rPr lang="en-US" smtClean="0"/>
+              <a:rPr lang="en-US"/>
               <a:t>Fourth level</a:t>
             </a:r>
           </a:p>
           <a:p>
             <a:pPr lvl="4"/>
             <a:r>
-              <a:rPr lang="en-US" smtClean="0"/>
+              <a:rPr lang="en-US"/>
               <a:t>Fifth level</a:t>
             </a:r>
-            <a:endParaRPr lang="en-US"/>
           </a:p>
         </p:txBody>
       </p:sp>
@@ -466,7 +478,7 @@
           <a:p>
             <a:fld id="{5BCAD085-E8A6-8845-BD4E-CB4CCA059FC4}" type="datetimeFigureOut">
               <a:rPr lang="en-US" smtClean="0"/>
-              <a:t>1/27/13</a:t>
+              <a:t>8/17/26</a:t>
             </a:fld>
             <a:endParaRPr lang="en-US"/>
           </a:p>
@@ -565,10 +577,9 @@
           <a:lstStyle/>
           <a:p>
             <a:r>
-              <a:rPr lang="en-US" smtClean="0"/>
+              <a:rPr lang="en-US"/>
               <a:t>Click to edit Master title style</a:t>
             </a:r>
-            <a:endParaRPr lang="en-US"/>
           </a:p>
         </p:txBody>
       </p:sp>
@@ -594,38 +605,37 @@
           <a:p>
             <a:pPr lvl="0"/>
             <a:r>
-              <a:rPr lang="en-US" smtClean="0"/>
+              <a:rPr lang="en-US"/>
               <a:t>Click to edit Master text styles</a:t>
             </a:r>
           </a:p>
           <a:p>
             <a:pPr lvl="1"/>
             <a:r>
-              <a:rPr lang="en-US" smtClean="0"/>
+              <a:rPr lang="en-US"/>
               <a:t>Second level</a:t>
             </a:r>
           </a:p>
           <a:p>
             <a:pPr lvl="2"/>
             <a:r>
-              <a:rPr lang="en-US" smtClean="0"/>
+              <a:rPr lang="en-US"/>
               <a:t>Third level</a:t>
             </a:r>
           </a:p>
           <a:p>
             <a:pPr lvl="3"/>
             <a:r>
-              <a:rPr lang="en-US" smtClean="0"/>
+              <a:rPr lang="en-US"/>
               <a:t>Fourth level</a:t>
             </a:r>
           </a:p>
           <a:p>
             <a:pPr lvl="4"/>
             <a:r>
-              <a:rPr lang="en-US" smtClean="0"/>
+              <a:rPr lang="en-US"/>
               <a:t>Fifth level</a:t>
             </a:r>
-            <a:endParaRPr lang="en-US"/>
           </a:p>
         </p:txBody>
       </p:sp>
@@ -646,7 +656,7 @@
           <a:p>
             <a:fld id="{5BCAD085-E8A6-8845-BD4E-CB4CCA059FC4}" type="datetimeFigureOut">
               <a:rPr lang="en-US" smtClean="0"/>
-              <a:t>1/27/13</a:t>
+              <a:t>8/17/26</a:t>
             </a:fld>
             <a:endParaRPr lang="en-US"/>
           </a:p>
@@ -740,10 +750,9 @@
           <a:lstStyle/>
           <a:p>
             <a:r>
-              <a:rPr lang="en-US" smtClean="0"/>
+              <a:rPr lang="en-US"/>
               <a:t>Click to edit Master title style</a:t>
             </a:r>
-            <a:endParaRPr lang="en-US"/>
           </a:p>
         </p:txBody>
       </p:sp>
@@ -764,38 +773,37 @@
           <a:p>
             <a:pPr lvl="0"/>
             <a:r>
-              <a:rPr lang="en-US" smtClean="0"/>
+              <a:rPr lang="en-US"/>
               <a:t>Click to edit Master text styles</a:t>
             </a:r>
           </a:p>
           <a:p>
             <a:pPr lvl="1"/>
             <a:r>
-              <a:rPr lang="en-US" smtClean="0"/>
+              <a:rPr lang="en-US"/>
               <a:t>Second level</a:t>
             </a:r>
           </a:p>
           <a:p>
             <a:pPr lvl="2"/>
             <a:r>
-              <a:rPr lang="en-US" smtClean="0"/>
+              <a:rPr lang="en-US"/>
               <a:t>Third level</a:t>
             </a:r>
           </a:p>
           <a:p>
             <a:pPr lvl="3"/>
             <a:r>
-              <a:rPr lang="en-US" smtClean="0"/>
+              <a:rPr lang="en-US"/>
               <a:t>Fourth level</a:t>
             </a:r>
           </a:p>
           <a:p>
             <a:pPr lvl="4"/>
             <a:r>
-              <a:rPr lang="en-US" smtClean="0"/>
+              <a:rPr lang="en-US"/>
               <a:t>Fifth level</a:t>
             </a:r>
-            <a:endParaRPr lang="en-US"/>
           </a:p>
         </p:txBody>
       </p:sp>
@@ -816,7 +824,7 @@
           <a:p>
             <a:fld id="{5BCAD085-E8A6-8845-BD4E-CB4CCA059FC4}" type="datetimeFigureOut">
               <a:rPr lang="en-US" smtClean="0"/>
-              <a:t>1/27/13</a:t>
+              <a:t>8/17/26</a:t>
             </a:fld>
             <a:endParaRPr lang="en-US"/>
           </a:p>
@@ -919,10 +927,9 @@
           </a:lstStyle>
           <a:p>
             <a:r>
-              <a:rPr lang="en-US" smtClean="0"/>
+              <a:rPr lang="en-US"/>
               <a:t>Click to edit Master title style</a:t>
             </a:r>
-            <a:endParaRPr lang="en-US"/>
           </a:p>
         </p:txBody>
       </p:sp>
@@ -1039,7 +1046,7 @@
           <a:p>
             <a:pPr lvl="0"/>
             <a:r>
-              <a:rPr lang="en-US" smtClean="0"/>
+              <a:rPr lang="en-US"/>
               <a:t>Click to edit Master text styles</a:t>
             </a:r>
           </a:p>
@@ -1062,7 +1069,7 @@
           <a:p>
             <a:fld id="{5BCAD085-E8A6-8845-BD4E-CB4CCA059FC4}" type="datetimeFigureOut">
               <a:rPr lang="en-US" smtClean="0"/>
-              <a:t>1/27/13</a:t>
+              <a:t>8/17/26</a:t>
             </a:fld>
             <a:endParaRPr lang="en-US"/>
           </a:p>
@@ -1156,10 +1163,9 @@
           <a:lstStyle/>
           <a:p>
             <a:r>
-              <a:rPr lang="en-US" smtClean="0"/>
+              <a:rPr lang="en-US"/>
               <a:t>Click to edit Master title style</a:t>
             </a:r>
-            <a:endParaRPr lang="en-US"/>
           </a:p>
         </p:txBody>
       </p:sp>
@@ -1213,38 +1219,37 @@
           <a:p>
             <a:pPr lvl="0"/>
             <a:r>
-              <a:rPr lang="en-US" smtClean="0"/>
+              <a:rPr lang="en-US"/>
               <a:t>Click to edit Master text styles</a:t>
             </a:r>
           </a:p>
           <a:p>
             <a:pPr lvl="1"/>
             <a:r>
-              <a:rPr lang="en-US" smtClean="0"/>
+              <a:rPr lang="en-US"/>
               <a:t>Second level</a:t>
             </a:r>
           </a:p>
           <a:p>
             <a:pPr lvl="2"/>
             <a:r>
-              <a:rPr lang="en-US" smtClean="0"/>
+              <a:rPr lang="en-US"/>
               <a:t>Third level</a:t>
             </a:r>
           </a:p>
           <a:p>
             <a:pPr lvl="3"/>
             <a:r>
-              <a:rPr lang="en-US" smtClean="0"/>
+              <a:rPr lang="en-US"/>
               <a:t>Fourth level</a:t>
             </a:r>
           </a:p>
           <a:p>
             <a:pPr lvl="4"/>
             <a:r>
-              <a:rPr lang="en-US" smtClean="0"/>
+              <a:rPr lang="en-US"/>
               <a:t>Fifth level</a:t>
             </a:r>
-            <a:endParaRPr lang="en-US"/>
           </a:p>
         </p:txBody>
       </p:sp>
@@ -1298,38 +1303,37 @@
           <a:p>
             <a:pPr lvl="0"/>
             <a:r>
-              <a:rPr lang="en-US" smtClean="0"/>
+              <a:rPr lang="en-US"/>
               <a:t>Click to edit Master text styles</a:t>
             </a:r>
           </a:p>
           <a:p>
             <a:pPr lvl="1"/>
             <a:r>
-              <a:rPr lang="en-US" smtClean="0"/>
+              <a:rPr lang="en-US"/>
               <a:t>Second level</a:t>
             </a:r>
           </a:p>
           <a:p>
             <a:pPr lvl="2"/>
             <a:r>
-              <a:rPr lang="en-US" smtClean="0"/>
+              <a:rPr lang="en-US"/>
               <a:t>Third level</a:t>
             </a:r>
           </a:p>
           <a:p>
             <a:pPr lvl="3"/>
             <a:r>
-              <a:rPr lang="en-US" smtClean="0"/>
+              <a:rPr lang="en-US"/>
               <a:t>Fourth level</a:t>
             </a:r>
           </a:p>
           <a:p>
             <a:pPr lvl="4"/>
             <a:r>
-              <a:rPr lang="en-US" smtClean="0"/>
+              <a:rPr lang="en-US"/>
               <a:t>Fifth level</a:t>
             </a:r>
-            <a:endParaRPr lang="en-US"/>
           </a:p>
         </p:txBody>
       </p:sp>
@@ -1350,7 +1354,7 @@
           <a:p>
             <a:fld id="{5BCAD085-E8A6-8845-BD4E-CB4CCA059FC4}" type="datetimeFigureOut">
               <a:rPr lang="en-US" smtClean="0"/>
-              <a:t>1/27/13</a:t>
+              <a:t>8/17/26</a:t>
             </a:fld>
             <a:endParaRPr lang="en-US"/>
           </a:p>
@@ -1448,10 +1452,9 @@
           </a:lstStyle>
           <a:p>
             <a:r>
-              <a:rPr lang="en-US" smtClean="0"/>
+              <a:rPr lang="en-US"/>
               <a:t>Click to edit Master title style</a:t>
             </a:r>
-            <a:endParaRPr lang="en-US"/>
           </a:p>
         </p:txBody>
       </p:sp>
@@ -1514,7 +1517,7 @@
           <a:p>
             <a:pPr lvl="0"/>
             <a:r>
-              <a:rPr lang="en-US" smtClean="0"/>
+              <a:rPr lang="en-US"/>
               <a:t>Click to edit Master text styles</a:t>
             </a:r>
           </a:p>
@@ -1570,38 +1573,37 @@
           <a:p>
             <a:pPr lvl="0"/>
             <a:r>
-              <a:rPr lang="en-US" smtClean="0"/>
+              <a:rPr lang="en-US"/>
               <a:t>Click to edit Master text styles</a:t>
             </a:r>
           </a:p>
           <a:p>
             <a:pPr lvl="1"/>
             <a:r>
-              <a:rPr lang="en-US" smtClean="0"/>
+              <a:rPr lang="en-US"/>
               <a:t>Second level</a:t>
             </a:r>
           </a:p>
           <a:p>
             <a:pPr lvl="2"/>
             <a:r>
-              <a:rPr lang="en-US" smtClean="0"/>
+              <a:rPr lang="en-US"/>
               <a:t>Third level</a:t>
             </a:r>
           </a:p>
           <a:p>
             <a:pPr lvl="3"/>
             <a:r>
-              <a:rPr lang="en-US" smtClean="0"/>
+              <a:rPr lang="en-US"/>
               <a:t>Fourth level</a:t>
             </a:r>
           </a:p>
           <a:p>
             <a:pPr lvl="4"/>
             <a:r>
-              <a:rPr lang="en-US" smtClean="0"/>
+              <a:rPr lang="en-US"/>
               <a:t>Fifth level</a:t>
             </a:r>
-            <a:endParaRPr lang="en-US"/>
           </a:p>
         </p:txBody>
       </p:sp>
@@ -1664,7 +1666,7 @@
           <a:p>
             <a:pPr lvl="0"/>
             <a:r>
-              <a:rPr lang="en-US" smtClean="0"/>
+              <a:rPr lang="en-US"/>
               <a:t>Click to edit Master text styles</a:t>
             </a:r>
           </a:p>
@@ -1720,38 +1722,37 @@
           <a:p>
             <a:pPr lvl="0"/>
             <a:r>
-              <a:rPr lang="en-US" smtClean="0"/>
+              <a:rPr lang="en-US"/>
               <a:t>Click to edit Master text styles</a:t>
             </a:r>
           </a:p>
           <a:p>
             <a:pPr lvl="1"/>
             <a:r>
-              <a:rPr lang="en-US" smtClean="0"/>
+              <a:rPr lang="en-US"/>
               <a:t>Second level</a:t>
             </a:r>
           </a:p>
           <a:p>
             <a:pPr lvl="2"/>
             <a:r>
-              <a:rPr lang="en-US" smtClean="0"/>
+              <a:rPr lang="en-US"/>
               <a:t>Third level</a:t>
             </a:r>
           </a:p>
           <a:p>
             <a:pPr lvl="3"/>
             <a:r>
-              <a:rPr lang="en-US" smtClean="0"/>
+              <a:rPr lang="en-US"/>
               <a:t>Fourth level</a:t>
             </a:r>
           </a:p>
           <a:p>
             <a:pPr lvl="4"/>
             <a:r>
-              <a:rPr lang="en-US" smtClean="0"/>
+              <a:rPr lang="en-US"/>
               <a:t>Fifth level</a:t>
             </a:r>
-            <a:endParaRPr lang="en-US"/>
           </a:p>
         </p:txBody>
       </p:sp>
@@ -1772,7 +1773,7 @@
           <a:p>
             <a:fld id="{5BCAD085-E8A6-8845-BD4E-CB4CCA059FC4}" type="datetimeFigureOut">
               <a:rPr lang="en-US" smtClean="0"/>
-              <a:t>1/27/13</a:t>
+              <a:t>8/17/26</a:t>
             </a:fld>
             <a:endParaRPr lang="en-US"/>
           </a:p>
@@ -1866,10 +1867,9 @@
           <a:lstStyle/>
           <a:p>
             <a:r>
-              <a:rPr lang="en-US" smtClean="0"/>
+              <a:rPr lang="en-US"/>
               <a:t>Click to edit Master title style</a:t>
             </a:r>
-            <a:endParaRPr lang="en-US"/>
           </a:p>
         </p:txBody>
       </p:sp>
@@ -1890,7 +1890,7 @@
           <a:p>
             <a:fld id="{5BCAD085-E8A6-8845-BD4E-CB4CCA059FC4}" type="datetimeFigureOut">
               <a:rPr lang="en-US" smtClean="0"/>
-              <a:t>1/27/13</a:t>
+              <a:t>8/17/26</a:t>
             </a:fld>
             <a:endParaRPr lang="en-US"/>
           </a:p>
@@ -1985,7 +1985,7 @@
           <a:p>
             <a:fld id="{5BCAD085-E8A6-8845-BD4E-CB4CCA059FC4}" type="datetimeFigureOut">
               <a:rPr lang="en-US" smtClean="0"/>
-              <a:t>1/27/13</a:t>
+              <a:t>8/17/26</a:t>
             </a:fld>
             <a:endParaRPr lang="en-US"/>
           </a:p>
@@ -2088,10 +2088,9 @@
           </a:lstStyle>
           <a:p>
             <a:r>
-              <a:rPr lang="en-US" smtClean="0"/>
+              <a:rPr lang="en-US"/>
               <a:t>Click to edit Master title style</a:t>
             </a:r>
-            <a:endParaRPr lang="en-US"/>
           </a:p>
         </p:txBody>
       </p:sp>
@@ -2145,38 +2144,37 @@
           <a:p>
             <a:pPr lvl="0"/>
             <a:r>
-              <a:rPr lang="en-US" smtClean="0"/>
+              <a:rPr lang="en-US"/>
               <a:t>Click to edit Master text styles</a:t>
             </a:r>
           </a:p>
           <a:p>
             <a:pPr lvl="1"/>
             <a:r>
-              <a:rPr lang="en-US" smtClean="0"/>
+              <a:rPr lang="en-US"/>
               <a:t>Second level</a:t>
             </a:r>
           </a:p>
           <a:p>
             <a:pPr lvl="2"/>
             <a:r>
-              <a:rPr lang="en-US" smtClean="0"/>
+              <a:rPr lang="en-US"/>
               <a:t>Third level</a:t>
             </a:r>
           </a:p>
           <a:p>
             <a:pPr lvl="3"/>
             <a:r>
-              <a:rPr lang="en-US" smtClean="0"/>
+              <a:rPr lang="en-US"/>
               <a:t>Fourth level</a:t>
             </a:r>
           </a:p>
           <a:p>
             <a:pPr lvl="4"/>
             <a:r>
-              <a:rPr lang="en-US" smtClean="0"/>
+              <a:rPr lang="en-US"/>
               <a:t>Fifth level</a:t>
             </a:r>
-            <a:endParaRPr lang="en-US"/>
           </a:p>
         </p:txBody>
       </p:sp>
@@ -2239,7 +2237,7 @@
           <a:p>
             <a:pPr lvl="0"/>
             <a:r>
-              <a:rPr lang="en-US" smtClean="0"/>
+              <a:rPr lang="en-US"/>
               <a:t>Click to edit Master text styles</a:t>
             </a:r>
           </a:p>
@@ -2262,7 +2260,7 @@
           <a:p>
             <a:fld id="{5BCAD085-E8A6-8845-BD4E-CB4CCA059FC4}" type="datetimeFigureOut">
               <a:rPr lang="en-US" smtClean="0"/>
-              <a:t>1/27/13</a:t>
+              <a:t>8/17/26</a:t>
             </a:fld>
             <a:endParaRPr lang="en-US"/>
           </a:p>
@@ -2365,10 +2363,9 @@
           </a:lstStyle>
           <a:p>
             <a:r>
-              <a:rPr lang="en-US" smtClean="0"/>
+              <a:rPr lang="en-US"/>
               <a:t>Click to edit Master title style</a:t>
             </a:r>
-            <a:endParaRPr lang="en-US"/>
           </a:p>
         </p:txBody>
       </p:sp>
@@ -2492,7 +2489,7 @@
           <a:p>
             <a:pPr lvl="0"/>
             <a:r>
-              <a:rPr lang="en-US" smtClean="0"/>
+              <a:rPr lang="en-US"/>
               <a:t>Click to edit Master text styles</a:t>
             </a:r>
           </a:p>
@@ -2515,7 +2512,7 @@
           <a:p>
             <a:fld id="{5BCAD085-E8A6-8845-BD4E-CB4CCA059FC4}" type="datetimeFigureOut">
               <a:rPr lang="en-US" smtClean="0"/>
-              <a:t>1/27/13</a:t>
+              <a:t>8/17/26</a:t>
             </a:fld>
             <a:endParaRPr lang="en-US"/>
           </a:p>
@@ -2624,10 +2621,9 @@
           <a:lstStyle/>
           <a:p>
             <a:r>
-              <a:rPr lang="en-US" smtClean="0"/>
+              <a:rPr lang="en-US"/>
               <a:t>Click to edit Master title style</a:t>
             </a:r>
-            <a:endParaRPr lang="en-US"/>
           </a:p>
         </p:txBody>
       </p:sp>
@@ -2658,38 +2654,37 @@
           <a:p>
             <a:pPr lvl="0"/>
             <a:r>
-              <a:rPr lang="en-US" smtClean="0"/>
+              <a:rPr lang="en-US"/>
               <a:t>Click to edit Master text styles</a:t>
             </a:r>
           </a:p>
           <a:p>
             <a:pPr lvl="1"/>
             <a:r>
-              <a:rPr lang="en-US" smtClean="0"/>
+              <a:rPr lang="en-US"/>
               <a:t>Second level</a:t>
             </a:r>
           </a:p>
           <a:p>
             <a:pPr lvl="2"/>
             <a:r>
-              <a:rPr lang="en-US" smtClean="0"/>
+              <a:rPr lang="en-US"/>
               <a:t>Third level</a:t>
             </a:r>
           </a:p>
           <a:p>
             <a:pPr lvl="3"/>
             <a:r>
-              <a:rPr lang="en-US" smtClean="0"/>
+              <a:rPr lang="en-US"/>
               <a:t>Fourth level</a:t>
             </a:r>
           </a:p>
           <a:p>
             <a:pPr lvl="4"/>
             <a:r>
-              <a:rPr lang="en-US" smtClean="0"/>
+              <a:rPr lang="en-US"/>
               <a:t>Fifth level</a:t>
             </a:r>
-            <a:endParaRPr lang="en-US"/>
           </a:p>
         </p:txBody>
       </p:sp>
@@ -2728,7 +2723,7 @@
           <a:p>
             <a:fld id="{5BCAD085-E8A6-8845-BD4E-CB4CCA059FC4}" type="datetimeFigureOut">
               <a:rPr lang="en-US" smtClean="0"/>
-              <a:t>1/27/13</a:t>
+              <a:t>8/17/26</a:t>
             </a:fld>
             <a:endParaRPr lang="en-US"/>
           </a:p>
@@ -3087,7 +3082,7 @@
 </file>
 
 <file path=ppt/slides/slide1.xml><?xml version="1.0" encoding="utf-8"?>
-<p:sld xmlns:a="http://schemas.openxmlformats.org/drawingml/2006/main" xmlns:p="http://schemas.openxmlformats.org/presentationml/2006/main" xmlns:r="http://schemas.openxmlformats.org/officeDocument/2006/relationships">
+<p:sld xmlns:a="http://schemas.openxmlformats.org/drawingml/2006/main" xmlns:r="http://schemas.openxmlformats.org/officeDocument/2006/relationships" xmlns:p="http://schemas.openxmlformats.org/presentationml/2006/main">
   <p:cSld>
     <p:bg>
       <p:bgPr>
@@ -3103,7 +3098,14 @@
         <p:cNvGrpSpPr/>
         <p:nvPr/>
       </p:nvGrpSpPr>
-      <p:grpSpPr/>
+      <p:grpSpPr>
+        <a:xfrm>
+          <a:off x="0" y="0"/>
+          <a:ext cx="0" cy="0"/>
+          <a:chOff x="0" y="0"/>
+          <a:chExt cx="0" cy="0"/>
+        </a:xfrm>
+      </p:grpSpPr>
       <p:sp>
         <p:nvSpPr>
           <p:cNvPr id="2" name="Rectangle 1"/>
@@ -3145,6 +3147,7 @@
           <a:lstStyle/>
           <a:p>
             <a:pPr algn="ctr"/>
+            <a:endParaRPr/>
           </a:p>
         </p:txBody>
       </p:sp>
@@ -3189,6 +3192,7 @@
           <a:lstStyle/>
           <a:p>
             <a:pPr algn="ctr"/>
+            <a:endParaRPr/>
           </a:p>
         </p:txBody>
       </p:sp>
@@ -3311,6 +3315,7 @@
           <a:lstStyle/>
           <a:p>
             <a:pPr algn="ctr"/>
+            <a:endParaRPr/>
           </a:p>
         </p:txBody>
       </p:sp>
@@ -3401,7 +3406,7 @@
 </file>
 
 <file path=ppt/slides/slide2.xml><?xml version="1.0" encoding="utf-8"?>
-<p:sld xmlns:a="http://schemas.openxmlformats.org/drawingml/2006/main" xmlns:p="http://schemas.openxmlformats.org/presentationml/2006/main" xmlns:r="http://schemas.openxmlformats.org/officeDocument/2006/relationships">
+<p:sld xmlns:a="http://schemas.openxmlformats.org/drawingml/2006/main" xmlns:r="http://schemas.openxmlformats.org/officeDocument/2006/relationships" xmlns:p="http://schemas.openxmlformats.org/presentationml/2006/main">
   <p:cSld>
     <p:bg>
       <p:bgPr>
@@ -3417,7 +3422,14 @@
         <p:cNvGrpSpPr/>
         <p:nvPr/>
       </p:nvGrpSpPr>
-      <p:grpSpPr/>
+      <p:grpSpPr>
+        <a:xfrm>
+          <a:off x="0" y="0"/>
+          <a:ext cx="0" cy="0"/>
+          <a:chOff x="0" y="0"/>
+          <a:chExt cx="0" cy="0"/>
+        </a:xfrm>
+      </p:grpSpPr>
       <p:sp>
         <p:nvSpPr>
           <p:cNvPr id="2" name="Rectangle 1"/>
@@ -3459,6 +3471,7 @@
           <a:lstStyle/>
           <a:p>
             <a:pPr algn="ctr"/>
+            <a:endParaRPr/>
           </a:p>
         </p:txBody>
       </p:sp>
@@ -3581,6 +3594,7 @@
           <a:lstStyle/>
           <a:p>
             <a:pPr algn="ctr"/>
+            <a:endParaRPr/>
           </a:p>
         </p:txBody>
       </p:sp>
@@ -3712,7 +3726,7 @@
 </file>
 
 <file path=ppt/slides/slide3.xml><?xml version="1.0" encoding="utf-8"?>
-<p:sld xmlns:a="http://schemas.openxmlformats.org/drawingml/2006/main" xmlns:p="http://schemas.openxmlformats.org/presentationml/2006/main" xmlns:r="http://schemas.openxmlformats.org/officeDocument/2006/relationships">
+<p:sld xmlns:a="http://schemas.openxmlformats.org/drawingml/2006/main" xmlns:r="http://schemas.openxmlformats.org/officeDocument/2006/relationships" xmlns:p="http://schemas.openxmlformats.org/presentationml/2006/main">
   <p:cSld>
     <p:bg>
       <p:bgPr>
@@ -3728,7 +3742,14 @@
         <p:cNvGrpSpPr/>
         <p:nvPr/>
       </p:nvGrpSpPr>
-      <p:grpSpPr/>
+      <p:grpSpPr>
+        <a:xfrm>
+          <a:off x="0" y="0"/>
+          <a:ext cx="0" cy="0"/>
+          <a:chOff x="0" y="0"/>
+          <a:chExt cx="0" cy="0"/>
+        </a:xfrm>
+      </p:grpSpPr>
       <p:sp>
         <p:nvSpPr>
           <p:cNvPr id="2" name="Rectangle 1"/>
@@ -3770,6 +3791,7 @@
           <a:lstStyle/>
           <a:p>
             <a:pPr algn="ctr"/>
+            <a:endParaRPr/>
           </a:p>
         </p:txBody>
       </p:sp>
@@ -3892,6 +3914,7 @@
           <a:lstStyle/>
           <a:p>
             <a:pPr algn="ctr"/>
+            <a:endParaRPr/>
           </a:p>
         </p:txBody>
       </p:sp>
@@ -3975,7 +3998,7 @@
 </file>
 
 <file path=ppt/slides/slide4.xml><?xml version="1.0" encoding="utf-8"?>
-<p:sld xmlns:a="http://schemas.openxmlformats.org/drawingml/2006/main" xmlns:p="http://schemas.openxmlformats.org/presentationml/2006/main" xmlns:r="http://schemas.openxmlformats.org/officeDocument/2006/relationships">
+<p:sld xmlns:a="http://schemas.openxmlformats.org/drawingml/2006/main" xmlns:r="http://schemas.openxmlformats.org/officeDocument/2006/relationships" xmlns:p="http://schemas.openxmlformats.org/presentationml/2006/main">
   <p:cSld>
     <p:bg>
       <p:bgPr>
@@ -3991,7 +4014,14 @@
         <p:cNvGrpSpPr/>
         <p:nvPr/>
       </p:nvGrpSpPr>
-      <p:grpSpPr/>
+      <p:grpSpPr>
+        <a:xfrm>
+          <a:off x="0" y="0"/>
+          <a:ext cx="0" cy="0"/>
+          <a:chOff x="0" y="0"/>
+          <a:chExt cx="0" cy="0"/>
+        </a:xfrm>
+      </p:grpSpPr>
       <p:sp>
         <p:nvSpPr>
           <p:cNvPr id="2" name="Rectangle 1"/>
@@ -4033,6 +4063,7 @@
           <a:lstStyle/>
           <a:p>
             <a:pPr algn="ctr"/>
+            <a:endParaRPr/>
           </a:p>
         </p:txBody>
       </p:sp>
@@ -4155,6 +4186,7 @@
           <a:lstStyle/>
           <a:p>
             <a:pPr algn="ctr"/>
+            <a:endParaRPr/>
           </a:p>
         </p:txBody>
       </p:sp>
@@ -4254,7 +4286,7 @@
 </file>
 
 <file path=ppt/slides/slide5.xml><?xml version="1.0" encoding="utf-8"?>
-<p:sld xmlns:a="http://schemas.openxmlformats.org/drawingml/2006/main" xmlns:p="http://schemas.openxmlformats.org/presentationml/2006/main" xmlns:r="http://schemas.openxmlformats.org/officeDocument/2006/relationships">
+<p:sld xmlns:a="http://schemas.openxmlformats.org/drawingml/2006/main" xmlns:r="http://schemas.openxmlformats.org/officeDocument/2006/relationships" xmlns:p="http://schemas.openxmlformats.org/presentationml/2006/main">
   <p:cSld>
     <p:bg>
       <p:bgPr>
@@ -4270,7 +4302,14 @@
         <p:cNvGrpSpPr/>
         <p:nvPr/>
       </p:nvGrpSpPr>
-      <p:grpSpPr/>
+      <p:grpSpPr>
+        <a:xfrm>
+          <a:off x="0" y="0"/>
+          <a:ext cx="0" cy="0"/>
+          <a:chOff x="0" y="0"/>
+          <a:chExt cx="0" cy="0"/>
+        </a:xfrm>
+      </p:grpSpPr>
       <p:sp>
         <p:nvSpPr>
           <p:cNvPr id="2" name="Rectangle 1"/>
@@ -4312,6 +4351,7 @@
           <a:lstStyle/>
           <a:p>
             <a:pPr algn="ctr"/>
+            <a:endParaRPr/>
           </a:p>
         </p:txBody>
       </p:sp>
@@ -4434,6 +4474,7 @@
           <a:lstStyle/>
           <a:p>
             <a:pPr algn="ctr"/>
+            <a:endParaRPr/>
           </a:p>
         </p:txBody>
       </p:sp>
@@ -4533,7 +4574,7 @@
 </file>
 
 <file path=ppt/slides/slide6.xml><?xml version="1.0" encoding="utf-8"?>
-<p:sld xmlns:a="http://schemas.openxmlformats.org/drawingml/2006/main" xmlns:p="http://schemas.openxmlformats.org/presentationml/2006/main" xmlns:r="http://schemas.openxmlformats.org/officeDocument/2006/relationships">
+<p:sld xmlns:a="http://schemas.openxmlformats.org/drawingml/2006/main" xmlns:r="http://schemas.openxmlformats.org/officeDocument/2006/relationships" xmlns:p="http://schemas.openxmlformats.org/presentationml/2006/main">
   <p:cSld>
     <p:bg>
       <p:bgPr>
@@ -4549,7 +4590,14 @@
         <p:cNvGrpSpPr/>
         <p:nvPr/>
       </p:nvGrpSpPr>
-      <p:grpSpPr/>
+      <p:grpSpPr>
+        <a:xfrm>
+          <a:off x="0" y="0"/>
+          <a:ext cx="0" cy="0"/>
+          <a:chOff x="0" y="0"/>
+          <a:chExt cx="0" cy="0"/>
+        </a:xfrm>
+      </p:grpSpPr>
       <p:sp>
         <p:nvSpPr>
           <p:cNvPr id="2" name="Rectangle 1"/>
@@ -4591,6 +4639,7 @@
           <a:lstStyle/>
           <a:p>
             <a:pPr algn="ctr"/>
+            <a:endParaRPr/>
           </a:p>
         </p:txBody>
       </p:sp>
@@ -4713,6 +4762,7 @@
           <a:lstStyle/>
           <a:p>
             <a:pPr algn="ctr"/>
+            <a:endParaRPr/>
           </a:p>
         </p:txBody>
       </p:sp>
@@ -4759,6 +4809,7 @@
           <a:lstStyle/>
           <a:p>
             <a:pPr algn="ctr"/>
+            <a:endParaRPr/>
           </a:p>
         </p:txBody>
       </p:sp>
@@ -4803,6 +4854,7 @@
           <a:lstStyle/>
           <a:p>
             <a:pPr algn="ctr"/>
+            <a:endParaRPr/>
           </a:p>
         </p:txBody>
       </p:sp>
@@ -4847,6 +4899,7 @@
           <a:lstStyle/>
           <a:p>
             <a:pPr algn="ctr"/>
+            <a:endParaRPr/>
           </a:p>
         </p:txBody>
       </p:sp>
@@ -5019,6 +5072,7 @@
           <a:lstStyle/>
           <a:p>
             <a:pPr algn="ctr"/>
+            <a:endParaRPr/>
           </a:p>
         </p:txBody>
       </p:sp>
@@ -5063,6 +5117,7 @@
           <a:lstStyle/>
           <a:p>
             <a:pPr algn="ctr"/>
+            <a:endParaRPr/>
           </a:p>
         </p:txBody>
       </p:sp>
@@ -5107,6 +5162,7 @@
           <a:lstStyle/>
           <a:p>
             <a:pPr algn="ctr"/>
+            <a:endParaRPr/>
           </a:p>
         </p:txBody>
       </p:sp>
@@ -5245,7 +5301,7 @@
 </file>
 
 <file path=ppt/slides/slide7.xml><?xml version="1.0" encoding="utf-8"?>
-<p:sld xmlns:a="http://schemas.openxmlformats.org/drawingml/2006/main" xmlns:p="http://schemas.openxmlformats.org/presentationml/2006/main" xmlns:r="http://schemas.openxmlformats.org/officeDocument/2006/relationships">
+<p:sld xmlns:a="http://schemas.openxmlformats.org/drawingml/2006/main" xmlns:r="http://schemas.openxmlformats.org/officeDocument/2006/relationships" xmlns:p="http://schemas.openxmlformats.org/presentationml/2006/main">
   <p:cSld>
     <p:bg>
       <p:bgPr>
@@ -5261,7 +5317,14 @@
         <p:cNvGrpSpPr/>
         <p:nvPr/>
       </p:nvGrpSpPr>
-      <p:grpSpPr/>
+      <p:grpSpPr>
+        <a:xfrm>
+          <a:off x="0" y="0"/>
+          <a:ext cx="0" cy="0"/>
+          <a:chOff x="0" y="0"/>
+          <a:chExt cx="0" cy="0"/>
+        </a:xfrm>
+      </p:grpSpPr>
       <p:sp>
         <p:nvSpPr>
           <p:cNvPr id="2" name="Rectangle 1"/>
@@ -5303,6 +5366,7 @@
           <a:lstStyle/>
           <a:p>
             <a:pPr algn="ctr"/>
+            <a:endParaRPr/>
           </a:p>
         </p:txBody>
       </p:sp>
@@ -5425,6 +5489,7 @@
           <a:lstStyle/>
           <a:p>
             <a:pPr algn="ctr"/>
+            <a:endParaRPr/>
           </a:p>
         </p:txBody>
       </p:sp>
@@ -5471,6 +5536,7 @@
           <a:lstStyle/>
           <a:p>
             <a:pPr algn="ctr"/>
+            <a:endParaRPr/>
           </a:p>
         </p:txBody>
       </p:sp>
@@ -5515,6 +5581,7 @@
           <a:lstStyle/>
           <a:p>
             <a:pPr algn="ctr"/>
+            <a:endParaRPr/>
           </a:p>
         </p:txBody>
       </p:sp>
@@ -5678,6 +5745,7 @@
           <a:lstStyle/>
           <a:p>
             <a:pPr algn="ctr"/>
+            <a:endParaRPr/>
           </a:p>
         </p:txBody>
       </p:sp>
@@ -5722,6 +5790,7 @@
           <a:lstStyle/>
           <a:p>
             <a:pPr algn="ctr"/>
+            <a:endParaRPr/>
           </a:p>
         </p:txBody>
       </p:sp>
@@ -5885,6 +5954,7 @@
           <a:lstStyle/>
           <a:p>
             <a:pPr algn="ctr"/>
+            <a:endParaRPr/>
           </a:p>
         </p:txBody>
       </p:sp>
@@ -5929,6 +5999,7 @@
           <a:lstStyle/>
           <a:p>
             <a:pPr algn="ctr"/>
+            <a:endParaRPr/>
           </a:p>
         </p:txBody>
       </p:sp>
@@ -6058,7 +6129,7 @@
 </file>
 
 <file path=ppt/slides/slide8.xml><?xml version="1.0" encoding="utf-8"?>
-<p:sld xmlns:a="http://schemas.openxmlformats.org/drawingml/2006/main" xmlns:p="http://schemas.openxmlformats.org/presentationml/2006/main" xmlns:r="http://schemas.openxmlformats.org/officeDocument/2006/relationships">
+<p:sld xmlns:a="http://schemas.openxmlformats.org/drawingml/2006/main" xmlns:r="http://schemas.openxmlformats.org/officeDocument/2006/relationships" xmlns:p="http://schemas.openxmlformats.org/presentationml/2006/main">
   <p:cSld>
     <p:bg>
       <p:bgPr>
@@ -6074,7 +6145,14 @@
         <p:cNvGrpSpPr/>
         <p:nvPr/>
       </p:nvGrpSpPr>
-      <p:grpSpPr/>
+      <p:grpSpPr>
+        <a:xfrm>
+          <a:off x="0" y="0"/>
+          <a:ext cx="0" cy="0"/>
+          <a:chOff x="0" y="0"/>
+          <a:chExt cx="0" cy="0"/>
+        </a:xfrm>
+      </p:grpSpPr>
       <p:sp>
         <p:nvSpPr>
           <p:cNvPr id="2" name="Rounded Rectangle 1"/>
@@ -6118,6 +6196,7 @@
           <a:lstStyle/>
           <a:p>
             <a:pPr algn="ctr"/>
+            <a:endParaRPr/>
           </a:p>
         </p:txBody>
       </p:sp>
@@ -6162,6 +6241,7 @@
           <a:lstStyle/>
           <a:p>
             <a:pPr algn="ctr"/>
+            <a:endParaRPr/>
           </a:p>
         </p:txBody>
       </p:sp>
@@ -6252,7 +6332,7 @@
         <p:spPr>
           <a:xfrm>
             <a:off x="1097280" y="2606040"/>
-            <a:ext cx="9875520" cy="3383280"/>
+            <a:ext cx="9875520" cy="2631490"/>
           </a:xfrm>
           <a:prstGeom prst="rect">
             <a:avLst/>
@@ -6271,13 +6351,49 @@
               </a:spcAft>
             </a:pPr>
             <a:r>
-              <a:rPr sz="2300">
+              <a:rPr sz="2300" dirty="0">
                 <a:solidFill>
                   <a:srgbClr val="2B2B2B"/>
                 </a:solidFill>
                 <a:latin typeface="Calibri"/>
               </a:rPr>
-              <a:t>•  Título con una palabra clave</a:t>
+              <a:t>•  </a:t>
+            </a:r>
+            <a:r>
+              <a:rPr sz="2300" dirty="0" err="1">
+                <a:solidFill>
+                  <a:srgbClr val="2B2B2B"/>
+                </a:solidFill>
+                <a:latin typeface="Calibri"/>
+              </a:rPr>
+              <a:t>Título</a:t>
+            </a:r>
+            <a:r>
+              <a:rPr sz="2300" dirty="0">
+                <a:solidFill>
+                  <a:srgbClr val="2B2B2B"/>
+                </a:solidFill>
+                <a:latin typeface="Calibri"/>
+              </a:rPr>
+              <a:t> con </a:t>
+            </a:r>
+            <a:r>
+              <a:rPr sz="2300" dirty="0" err="1">
+                <a:solidFill>
+                  <a:srgbClr val="2B2B2B"/>
+                </a:solidFill>
+                <a:latin typeface="Calibri"/>
+              </a:rPr>
+              <a:t>una</a:t>
+            </a:r>
+            <a:r>
+              <a:rPr sz="2300" dirty="0">
+                <a:solidFill>
+                  <a:srgbClr val="2B2B2B"/>
+                </a:solidFill>
+                <a:latin typeface="Calibri"/>
+              </a:rPr>
+              <a:t> palabra clave</a:t>
             </a:r>
           </a:p>
           <a:p>
@@ -6287,14 +6403,119 @@
               </a:spcAft>
             </a:pPr>
             <a:r>
-              <a:rPr sz="2300">
+              <a:rPr sz="2300" dirty="0">
                 <a:solidFill>
                   <a:srgbClr val="2B2B2B"/>
                 </a:solidFill>
                 <a:latin typeface="Calibri"/>
               </a:rPr>
-              <a:t>•  Descripción corta (1 frase de gancho) y descripción larga</a:t>
-            </a:r>
+              <a:t>•  </a:t>
+            </a:r>
+            <a:r>
+              <a:rPr sz="2300" dirty="0" err="1">
+                <a:solidFill>
+                  <a:srgbClr val="2B2B2B"/>
+                </a:solidFill>
+                <a:latin typeface="Calibri"/>
+              </a:rPr>
+              <a:t>Descripción</a:t>
+            </a:r>
+            <a:r>
+              <a:rPr sz="2300" dirty="0">
+                <a:solidFill>
+                  <a:srgbClr val="2B2B2B"/>
+                </a:solidFill>
+                <a:latin typeface="Calibri"/>
+              </a:rPr>
+              <a:t> </a:t>
+            </a:r>
+            <a:r>
+              <a:rPr sz="2300" dirty="0" err="1">
+                <a:solidFill>
+                  <a:srgbClr val="2B2B2B"/>
+                </a:solidFill>
+                <a:latin typeface="Calibri"/>
+              </a:rPr>
+              <a:t>corta</a:t>
+            </a:r>
+            <a:r>
+              <a:rPr sz="2300" dirty="0">
+                <a:solidFill>
+                  <a:srgbClr val="2B2B2B"/>
+                </a:solidFill>
+                <a:latin typeface="Calibri"/>
+              </a:rPr>
+              <a:t> (1 </a:t>
+            </a:r>
+            <a:r>
+              <a:rPr sz="2300" dirty="0" err="1">
+                <a:solidFill>
+                  <a:srgbClr val="2B2B2B"/>
+                </a:solidFill>
+                <a:latin typeface="Calibri"/>
+              </a:rPr>
+              <a:t>frase</a:t>
+            </a:r>
+            <a:r>
+              <a:rPr sz="2300" dirty="0">
+                <a:solidFill>
+                  <a:srgbClr val="2B2B2B"/>
+                </a:solidFill>
+                <a:latin typeface="Calibri"/>
+              </a:rPr>
+              <a:t> de </a:t>
+            </a:r>
+            <a:r>
+              <a:rPr sz="2300" dirty="0" err="1">
+                <a:solidFill>
+                  <a:srgbClr val="2B2B2B"/>
+                </a:solidFill>
+                <a:latin typeface="Calibri"/>
+              </a:rPr>
+              <a:t>gancho</a:t>
+            </a:r>
+            <a:r>
+              <a:rPr sz="2300" dirty="0">
+                <a:solidFill>
+                  <a:srgbClr val="2B2B2B"/>
+                </a:solidFill>
+                <a:latin typeface="Calibri"/>
+              </a:rPr>
+              <a:t>) y </a:t>
+            </a:r>
+            <a:r>
+              <a:rPr sz="2300" dirty="0" err="1">
+                <a:solidFill>
+                  <a:srgbClr val="2B2B2B"/>
+                </a:solidFill>
+                <a:latin typeface="Calibri"/>
+              </a:rPr>
+              <a:t>descripción</a:t>
+            </a:r>
+            <a:r>
+              <a:rPr sz="2300" dirty="0">
+                <a:solidFill>
+                  <a:srgbClr val="2B2B2B"/>
+                </a:solidFill>
+                <a:latin typeface="Calibri"/>
+              </a:rPr>
+              <a:t> </a:t>
+            </a:r>
+            <a:r>
+              <a:rPr sz="2300" dirty="0" err="1">
+                <a:solidFill>
+                  <a:srgbClr val="2B2B2B"/>
+                </a:solidFill>
+                <a:latin typeface="Calibri"/>
+              </a:rPr>
+              <a:t>larga</a:t>
+            </a:r>
+            <a:endParaRPr sz="2300" dirty="0">
+              <a:solidFill>
+                <a:srgbClr val="2B2B2B"/>
+              </a:solidFill>
+              <a:latin typeface="Calibri"/>
+            </a:endParaRPr>
           </a:p>
           <a:p>
             <a:pPr>
@@ -6303,13 +6524,31 @@
               </a:spcAft>
             </a:pPr>
             <a:r>
-              <a:rPr sz="2300">
+              <a:rPr lang="en-US" sz="2300" dirty="0">
                 <a:solidFill>
                   <a:srgbClr val="2B2B2B"/>
                 </a:solidFill>
                 <a:latin typeface="Calibri"/>
               </a:rPr>
-              <a:t>•  Ícono ya pulido en la sesión 7</a:t>
+              <a:t>•  </a:t>
+            </a:r>
+            <a:r>
+              <a:rPr lang="en-US" sz="2300" dirty="0" err="1">
+                <a:solidFill>
+                  <a:srgbClr val="2B2B2B"/>
+                </a:solidFill>
+                <a:latin typeface="Calibri"/>
+              </a:rPr>
+              <a:t>Ícono</a:t>
+            </a:r>
+            <a:r>
+              <a:rPr lang="en-US" sz="2300" dirty="0">
+                <a:solidFill>
+                  <a:srgbClr val="2B2B2B"/>
+                </a:solidFill>
+                <a:latin typeface="Calibri"/>
+              </a:rPr>
+              <a:t> (1024x1024)</a:t>
             </a:r>
           </a:p>
           <a:p>
@@ -6319,13 +6558,103 @@
               </a:spcAft>
             </a:pPr>
             <a:r>
-              <a:rPr sz="2300">
+              <a:rPr sz="2300" dirty="0">
                 <a:solidFill>
                   <a:srgbClr val="2B2B2B"/>
                 </a:solidFill>
                 <a:latin typeface="Calibri"/>
               </a:rPr>
-              <a:t>•  2–3 capturas que comuniquen el valor (salen de la vista previa o del teléfono)</a:t>
+              <a:t>•  2–3 </a:t>
+            </a:r>
+            <a:r>
+              <a:rPr sz="2300" dirty="0" err="1">
+                <a:solidFill>
+                  <a:srgbClr val="2B2B2B"/>
+                </a:solidFill>
+                <a:latin typeface="Calibri"/>
+              </a:rPr>
+              <a:t>capturas</a:t>
+            </a:r>
+            <a:r>
+              <a:rPr sz="2300" dirty="0">
+                <a:solidFill>
+                  <a:srgbClr val="2B2B2B"/>
+                </a:solidFill>
+                <a:latin typeface="Calibri"/>
+              </a:rPr>
+              <a:t> </a:t>
+            </a:r>
+            <a:r>
+              <a:rPr sz="2300" dirty="0" err="1">
+                <a:solidFill>
+                  <a:srgbClr val="2B2B2B"/>
+                </a:solidFill>
+                <a:latin typeface="Calibri"/>
+              </a:rPr>
+              <a:t>que</a:t>
+            </a:r>
+            <a:r>
+              <a:rPr sz="2300" dirty="0">
+                <a:solidFill>
+                  <a:srgbClr val="2B2B2B"/>
+                </a:solidFill>
+                <a:latin typeface="Calibri"/>
+              </a:rPr>
+              <a:t> </a:t>
+            </a:r>
+            <a:r>
+              <a:rPr sz="2300" dirty="0" err="1">
+                <a:solidFill>
+                  <a:srgbClr val="2B2B2B"/>
+                </a:solidFill>
+                <a:latin typeface="Calibri"/>
+              </a:rPr>
+              <a:t>comuniquen</a:t>
+            </a:r>
+            <a:r>
+              <a:rPr sz="2300" dirty="0">
+                <a:solidFill>
+                  <a:srgbClr val="2B2B2B"/>
+                </a:solidFill>
+                <a:latin typeface="Calibri"/>
+              </a:rPr>
+              <a:t> el valor (</a:t>
+            </a:r>
+            <a:r>
+              <a:rPr sz="2300" dirty="0" err="1">
+                <a:solidFill>
+                  <a:srgbClr val="2B2B2B"/>
+                </a:solidFill>
+                <a:latin typeface="Calibri"/>
+              </a:rPr>
+              <a:t>salen</a:t>
+            </a:r>
+            <a:r>
+              <a:rPr sz="2300" dirty="0">
+                <a:solidFill>
+                  <a:srgbClr val="2B2B2B"/>
+                </a:solidFill>
+                <a:latin typeface="Calibri"/>
+              </a:rPr>
+              <a:t> de la vista previa o del </a:t>
+            </a:r>
+            <a:r>
+              <a:rPr sz="2300" dirty="0" err="1">
+                <a:solidFill>
+                  <a:srgbClr val="2B2B2B"/>
+                </a:solidFill>
+                <a:latin typeface="Calibri"/>
+              </a:rPr>
+              <a:t>teléfono</a:t>
+            </a:r>
+            <a:r>
+              <a:rPr sz="2300" dirty="0">
+                <a:solidFill>
+                  <a:srgbClr val="2B2B2B"/>
+                </a:solidFill>
+                <a:latin typeface="Calibri"/>
+              </a:rPr>
+              <a:t>)</a:t>
             </a:r>
           </a:p>
           <a:p>
@@ -6335,13 +6664,67 @@
               </a:spcAft>
             </a:pPr>
             <a:r>
-              <a:rPr sz="2300">
+              <a:rPr sz="2300" dirty="0">
                 <a:solidFill>
                   <a:srgbClr val="2B2B2B"/>
                 </a:solidFill>
                 <a:latin typeface="Calibri"/>
               </a:rPr>
-              <a:t>•  Categoría sugerida en la tienda</a:t>
+              <a:t>•  </a:t>
+            </a:r>
+            <a:r>
+              <a:rPr sz="2300" dirty="0" err="1">
+                <a:solidFill>
+                  <a:srgbClr val="2B2B2B"/>
+                </a:solidFill>
+                <a:latin typeface="Calibri"/>
+              </a:rPr>
+              <a:t>Categoría</a:t>
+            </a:r>
+            <a:r>
+              <a:rPr sz="2300" dirty="0">
+                <a:solidFill>
+                  <a:srgbClr val="2B2B2B"/>
+                </a:solidFill>
+                <a:latin typeface="Calibri"/>
+              </a:rPr>
+              <a:t> </a:t>
+            </a:r>
+            <a:r>
+              <a:rPr sz="2300" dirty="0" err="1">
+                <a:solidFill>
+                  <a:srgbClr val="2B2B2B"/>
+                </a:solidFill>
+                <a:latin typeface="Calibri"/>
+              </a:rPr>
+              <a:t>sugerida</a:t>
+            </a:r>
+            <a:r>
+              <a:rPr sz="2300" dirty="0">
+                <a:solidFill>
+                  <a:srgbClr val="2B2B2B"/>
+                </a:solidFill>
+                <a:latin typeface="Calibri"/>
+              </a:rPr>
+              <a:t> </a:t>
+            </a:r>
+            <a:r>
+              <a:rPr sz="2300" dirty="0" err="1">
+                <a:solidFill>
+                  <a:srgbClr val="2B2B2B"/>
+                </a:solidFill>
+                <a:latin typeface="Calibri"/>
+              </a:rPr>
+              <a:t>en</a:t>
+            </a:r>
+            <a:r>
+              <a:rPr sz="2300" dirty="0">
+                <a:solidFill>
+                  <a:srgbClr val="2B2B2B"/>
+                </a:solidFill>
+                <a:latin typeface="Calibri"/>
+              </a:rPr>
+              <a:t> la tienda</a:t>
             </a:r>
           </a:p>
         </p:txBody>
@@ -6355,7 +6738,7 @@
 </file>
 
 <file path=ppt/slides/slide9.xml><?xml version="1.0" encoding="utf-8"?>
-<p:sld xmlns:a="http://schemas.openxmlformats.org/drawingml/2006/main" xmlns:p="http://schemas.openxmlformats.org/presentationml/2006/main" xmlns:r="http://schemas.openxmlformats.org/officeDocument/2006/relationships">
+<p:sld xmlns:a="http://schemas.openxmlformats.org/drawingml/2006/main" xmlns:r="http://schemas.openxmlformats.org/officeDocument/2006/relationships" xmlns:p="http://schemas.openxmlformats.org/presentationml/2006/main">
   <p:cSld>
     <p:bg>
       <p:bgPr>
@@ -6371,7 +6754,14 @@
         <p:cNvGrpSpPr/>
         <p:nvPr/>
       </p:nvGrpSpPr>
-      <p:grpSpPr/>
+      <p:grpSpPr>
+        <a:xfrm>
+          <a:off x="0" y="0"/>
+          <a:ext cx="0" cy="0"/>
+          <a:chOff x="0" y="0"/>
+          <a:chExt cx="0" cy="0"/>
+        </a:xfrm>
+      </p:grpSpPr>
       <p:sp>
         <p:nvSpPr>
           <p:cNvPr id="2" name="Rectangle 1"/>
@@ -6413,6 +6803,7 @@
           <a:lstStyle/>
           <a:p>
             <a:pPr algn="ctr"/>
+            <a:endParaRPr/>
           </a:p>
         </p:txBody>
       </p:sp>
@@ -6535,6 +6926,7 @@
           <a:lstStyle/>
           <a:p>
             <a:pPr algn="ctr"/>
+            <a:endParaRPr/>
           </a:p>
         </p:txBody>
       </p:sp>
@@ -6579,6 +6971,7 @@
           <a:lstStyle/>
           <a:p>
             <a:pPr algn="ctr"/>
+            <a:endParaRPr/>
           </a:p>
         </p:txBody>
       </p:sp>
@@ -6733,6 +7126,7 @@
           <a:lstStyle/>
           <a:p>
             <a:pPr algn="ctr"/>
+            <a:endParaRPr/>
           </a:p>
         </p:txBody>
       </p:sp>

</xml_diff>